<commit_message>
Refresh strategy deck — the prize is shipped
Slide 10 ("the prize") and the slide-12 plan framed commitment & procurement
optimization as the next build / a race to win. It's now shipped (PRs #256-273:
engine + CLI + console recommender, provisioned break-even, pacing, negotiation
pack, advisory caching/batch). Reframed to the stronger, accurate investor story:
the high-$ expansion lever is already built, ahead of Flexera, from a
work-attributed-data position they don't have. Slide 10 band recolored from
amber "race" to green "built before they stitched it"; the plan now lists the
prize as done-early with the next step being multi-provider portfolio.

Rebuilt: 12 slides, notes on all, zero overflow.

Co-Authored-By: Claude Opus 4.8 <noreply@anthropic.com>
Claude-Session: https://claude.ai/code/session_01Mev79UpmJmZS58W3eyakhL
</commit_message>
<xml_diff>
--- a/docs/outlay-strategy-deck.pptx
+++ b/docs/outlay-strategy-deck.pptx
@@ -583,7 +583,7 @@
           <a:lstStyle/>
           <a:p>
             <a:r>
-              <a:t>This is the high-$ expansion and the reason to own the core data first. Spec'd in docs/spec-commitment-optimization.md.</a:t>
+              <a:t>The high-$ expansion is no longer a plan — it's shipped (engine + CLI + console: recommender, provisioned break-even, pacing, negotiation pack, advisory caching/batch). Spec: docs/spec-commitment-optimization.md.</a:t>
             </a:r>
           </a:p>
         </p:txBody>
@@ -723,7 +723,7 @@
           <a:lstStyle/>
           <a:p>
             <a:r>
-              <a:t>Close: the data asset compounds — more spend under management = more lock-in. Ask / next step per the audience.</a:t>
+              <a:t>Close: the data asset compounds — more spend under management = more lock-in. The high-$ expansion is already built, ahead of schedule. Ask / next step per the audience.</a:t>
             </a:r>
           </a:p>
         </p:txBody>
@@ -4624,7 +4624,7 @@
         <p:spPr>
           <a:xfrm>
             <a:off x="548640" y="457200"/>
-            <a:ext cx="4206240" cy="502920"/>
+            <a:ext cx="4480560" cy="502920"/>
           </a:xfrm>
           <a:prstGeom prst="rect">
             <a:avLst/>
@@ -4667,7 +4667,7 @@
                 </a:solidFill>
                 <a:latin typeface="Calibri"/>
               </a:rPr>
-              <a:t>THE PRIZE · INCREMENTAL TAM</a:t>
+              <a:t>THE PRIZE · ALREADY SHIPPED</a:t>
             </a:r>
           </a:p>
         </p:txBody>
@@ -4761,7 +4761,7 @@
                 </a:solidFill>
                 <a:latin typeface="Calibri"/>
               </a:rPr>
-              <a:t>•  Getting it right needs forecasting + attribution — exactly our core data.</a:t>
+              <a:t>•  Getting it right needs forecasting + attribution — exactly our core data. The highest-$ FinOps lever (cloud analog: 30–60% savings).</a:t>
             </a:r>
           </a:p>
           <a:p>
@@ -4777,7 +4777,7 @@
                 </a:solidFill>
                 <a:latin typeface="Calibri"/>
               </a:rPr>
-              <a:t>•  Cloud analog (ProsperOps/Zesty/nOps) is the single highest-$ FinOps lever — 30–60% savings cited.</a:t>
+              <a:t>•  Built it: recommend the commit, size it against forfeit risk, pace it, export a vendor negotiation pack — live in-product.</a:t>
             </a:r>
           </a:p>
           <a:p>
@@ -4793,7 +4793,7 @@
                 </a:solidFill>
                 <a:latin typeface="Calibri"/>
               </a:rPr>
-              <a:t>•  Open at the model-API layer; our work-attributed steadiness signal beats an infra-only optimizer.</a:t>
+              <a:t>•  Our work-attributed steadiness signal beats an infra-only optimizer — the moat applied to procurement.</a:t>
             </a:r>
           </a:p>
         </p:txBody>
@@ -4813,7 +4813,7 @@
             <a:avLst/>
           </a:prstGeom>
           <a:solidFill>
-            <a:srgbClr val="F6ECDC"/>
+            <a:srgbClr val="E7F1EC"/>
           </a:solidFill>
           <a:ln>
             <a:noFill/>
@@ -4846,11 +4846,11 @@
             <a:r>
               <a:rPr sz="1400" b="1">
                 <a:solidFill>
-                  <a:srgbClr val="9A5A18"/>
+                  <a:srgbClr val="0B513C"/>
                 </a:solidFill>
                 <a:latin typeface="Georgia"/>
               </a:rPr>
-              <a:t>Race Flexera (now owns ProsperOps + FinOps-for-AI) to stitch this — from a better-data position</a:t>
+              <a:t>Built before Flexera (ProsperOps + FinOps-for-AI) stitched the model-API layer — from data they don't have</a:t>
             </a:r>
           </a:p>
         </p:txBody>
@@ -5620,7 +5620,7 @@
                 </a:solidFill>
                 <a:latin typeface="Calibri"/>
               </a:rPr>
-              <a:t>•  T</a:t>
+              <a:t>•  D</a:t>
             </a:r>
           </a:p>
           <a:p>

</xml_diff>

<commit_message>
Refresh strategy deck — the prize is shipped (#275)
Slide 10 ("the prize") and the slide-12 plan framed commitment & procurement
optimization as the next build / a race to win. It's now shipped (PRs #256-273:
engine + CLI + console recommender, provisioned break-even, pacing, negotiation
pack, advisory caching/batch). Reframed to the stronger, accurate investor story:
the high-$ expansion lever is already built, ahead of Flexera, from a
work-attributed-data position they don't have. Slide 10 band recolored from
amber "race" to green "built before they stitched it"; the plan now lists the
prize as done-early with the next step being multi-provider portfolio.

Rebuilt: 12 slides, notes on all, zero overflow.


Claude-Session: https://claude.ai/code/session_01Mev79UpmJmZS58W3eyakhL

Co-authored-by: Claude <noreply@anthropic.com>
</commit_message>
<xml_diff>
--- a/docs/outlay-strategy-deck.pptx
+++ b/docs/outlay-strategy-deck.pptx
@@ -583,7 +583,7 @@
           <a:lstStyle/>
           <a:p>
             <a:r>
-              <a:t>This is the high-$ expansion and the reason to own the core data first. Spec'd in docs/spec-commitment-optimization.md.</a:t>
+              <a:t>The high-$ expansion is no longer a plan — it's shipped (engine + CLI + console: recommender, provisioned break-even, pacing, negotiation pack, advisory caching/batch). Spec: docs/spec-commitment-optimization.md.</a:t>
             </a:r>
           </a:p>
         </p:txBody>
@@ -723,7 +723,7 @@
           <a:lstStyle/>
           <a:p>
             <a:r>
-              <a:t>Close: the data asset compounds — more spend under management = more lock-in. Ask / next step per the audience.</a:t>
+              <a:t>Close: the data asset compounds — more spend under management = more lock-in. The high-$ expansion is already built, ahead of schedule. Ask / next step per the audience.</a:t>
             </a:r>
           </a:p>
         </p:txBody>
@@ -4624,7 +4624,7 @@
         <p:spPr>
           <a:xfrm>
             <a:off x="548640" y="457200"/>
-            <a:ext cx="4206240" cy="502920"/>
+            <a:ext cx="4480560" cy="502920"/>
           </a:xfrm>
           <a:prstGeom prst="rect">
             <a:avLst/>
@@ -4667,7 +4667,7 @@
                 </a:solidFill>
                 <a:latin typeface="Calibri"/>
               </a:rPr>
-              <a:t>THE PRIZE · INCREMENTAL TAM</a:t>
+              <a:t>THE PRIZE · ALREADY SHIPPED</a:t>
             </a:r>
           </a:p>
         </p:txBody>
@@ -4761,7 +4761,7 @@
                 </a:solidFill>
                 <a:latin typeface="Calibri"/>
               </a:rPr>
-              <a:t>•  Getting it right needs forecasting + attribution — exactly our core data.</a:t>
+              <a:t>•  Getting it right needs forecasting + attribution — exactly our core data. The highest-$ FinOps lever (cloud analog: 30–60% savings).</a:t>
             </a:r>
           </a:p>
           <a:p>
@@ -4777,7 +4777,7 @@
                 </a:solidFill>
                 <a:latin typeface="Calibri"/>
               </a:rPr>
-              <a:t>•  Cloud analog (ProsperOps/Zesty/nOps) is the single highest-$ FinOps lever — 30–60% savings cited.</a:t>
+              <a:t>•  Built it: recommend the commit, size it against forfeit risk, pace it, export a vendor negotiation pack — live in-product.</a:t>
             </a:r>
           </a:p>
           <a:p>
@@ -4793,7 +4793,7 @@
                 </a:solidFill>
                 <a:latin typeface="Calibri"/>
               </a:rPr>
-              <a:t>•  Open at the model-API layer; our work-attributed steadiness signal beats an infra-only optimizer.</a:t>
+              <a:t>•  Our work-attributed steadiness signal beats an infra-only optimizer — the moat applied to procurement.</a:t>
             </a:r>
           </a:p>
         </p:txBody>
@@ -4813,7 +4813,7 @@
             <a:avLst/>
           </a:prstGeom>
           <a:solidFill>
-            <a:srgbClr val="F6ECDC"/>
+            <a:srgbClr val="E7F1EC"/>
           </a:solidFill>
           <a:ln>
             <a:noFill/>
@@ -4846,11 +4846,11 @@
             <a:r>
               <a:rPr sz="1400" b="1">
                 <a:solidFill>
-                  <a:srgbClr val="9A5A18"/>
+                  <a:srgbClr val="0B513C"/>
                 </a:solidFill>
                 <a:latin typeface="Georgia"/>
               </a:rPr>
-              <a:t>Race Flexera (now owns ProsperOps + FinOps-for-AI) to stitch this — from a better-data position</a:t>
+              <a:t>Built before Flexera (ProsperOps + FinOps-for-AI) stitched the model-API layer — from data they don't have</a:t>
             </a:r>
           </a:p>
         </p:txBody>
@@ -5620,7 +5620,7 @@
                 </a:solidFill>
                 <a:latin typeface="Calibri"/>
               </a:rPr>
-              <a:t>•  T</a:t>
+              <a:t>•  D</a:t>
             </a:r>
           </a:p>
           <a:p>

</xml_diff>